<commit_message>
fix typos in slides of week 5
</commit_message>
<xml_diff>
--- a/cits1003-lecture_slides/CITS1003-5 Vulnerabilities-exercises.pptx
+++ b/cits1003-lecture_slides/CITS1003-5 Vulnerabilities-exercises.pptx
@@ -14046,7 +14046,7 @@
           </a:effectLst>
           <a:extLst>
             <a:ext uri="{91240B29-F687-4f45-9708-019B960494DF}">
-              <a14:hiddenLine xmlns="" xmlns:a14="http://schemas.microsoft.com/office/drawing/2010/main" xmlns:p14="http://schemas.microsoft.com/office/powerpoint/2010/main" xmlns:a16="http://schemas.microsoft.com/office/drawing/2014/main" w="9525">
+              <a14:hiddenLine xmlns:a16="http://schemas.microsoft.com/office/drawing/2014/main" xmlns:p14="http://schemas.microsoft.com/office/powerpoint/2010/main" xmlns:a14="http://schemas.microsoft.com/office/drawing/2010/main" xmlns="" w="9525">
                 <a:solidFill>
                   <a:srgbClr val="000000"/>
                 </a:solidFill>
@@ -25595,7 +25595,7 @@
           <a:p>
             <a:r>
               <a:rPr lang="en-AU" sz="2800" dirty="0"/>
-              <a:t>How dangerous is this vulnerability?</a:t>
+              <a:t>How dangerous is SQLi?</a:t>
             </a:r>
           </a:p>
           <a:p>
@@ -32435,7 +32435,7 @@
             </a:r>
             <a:r>
               <a:rPr lang="en-AU" sz="2800" dirty="0"/>
-              <a:t>‘$target’ is a variable and its value is decided by user inputs. The value is not sanitized before it is executed by the web application.</a:t>
+              <a:t>‘$target’ is a variable and its value is decided by user inputs. The inputs are not sanitized before they are executed by the web application.</a:t>
             </a:r>
           </a:p>
           <a:p>

</xml_diff>